<commit_message>
Apresentação: atualiza PPTX base e versões revisadas (v2 e slide15)
Co-authored-by: Cursor <cursoragent@cursor.com>
</commit_message>
<xml_diff>
--- a/reports/Apresentacao_NPS_Fase1.pptx
+++ b/reports/Apresentacao_NPS_Fase1.pptx
@@ -12,12 +12,14 @@
     <p:sldId id="259" r:id="rId6"/>
     <p:sldId id="267" r:id="rId7"/>
     <p:sldId id="266" r:id="rId8"/>
-    <p:sldId id="260" r:id="rId9"/>
-    <p:sldId id="268" r:id="rId10"/>
-    <p:sldId id="261" r:id="rId11"/>
-    <p:sldId id="262" r:id="rId12"/>
-    <p:sldId id="263" r:id="rId13"/>
-    <p:sldId id="264" r:id="rId14"/>
+    <p:sldId id="269" r:id="rId9"/>
+    <p:sldId id="260" r:id="rId10"/>
+    <p:sldId id="268" r:id="rId11"/>
+    <p:sldId id="261" r:id="rId12"/>
+    <p:sldId id="262" r:id="rId13"/>
+    <p:sldId id="270" r:id="rId14"/>
+    <p:sldId id="263" r:id="rId15"/>
+    <p:sldId id="264" r:id="rId16"/>
   </p:sldIdLst>
   <p:sldSz cx="9144000" cy="6858000" type="screen4x3"/>
   <p:notesSz cx="6858000" cy="9144000"/>
@@ -447,6 +449,13 @@
               <a:tailEnd/>
             </a:ln>
           </p:spPr>
+          <p:txBody>
+            <a:bodyPr/>
+            <a:lstStyle/>
+            <a:p>
+              <a:endParaRPr lang="pt-BR"/>
+            </a:p>
+          </p:txBody>
         </p:sp>
         <p:sp>
           <p:nvSpPr>
@@ -505,6 +514,13 @@
               <a:tailEnd/>
             </a:ln>
           </p:spPr>
+          <p:txBody>
+            <a:bodyPr/>
+            <a:lstStyle/>
+            <a:p>
+              <a:endParaRPr lang="pt-BR"/>
+            </a:p>
+          </p:txBody>
         </p:sp>
       </p:grpSp>
     </p:spTree>
@@ -3610,6 +3626,13 @@
             <a:schemeClr val="lt1"/>
           </a:fontRef>
         </p:style>
+        <p:txBody>
+          <a:bodyPr/>
+          <a:lstStyle/>
+          <a:p>
+            <a:endParaRPr lang="pt-BR"/>
+          </a:p>
+        </p:txBody>
       </p:sp>
       <p:sp>
         <p:nvSpPr>
@@ -3648,6 +3671,13 @@
             <a:schemeClr val="lt1"/>
           </a:fontRef>
         </p:style>
+        <p:txBody>
+          <a:bodyPr/>
+          <a:lstStyle/>
+          <a:p>
+            <a:endParaRPr lang="pt-BR"/>
+          </a:p>
+        </p:txBody>
       </p:sp>
     </p:spTree>
     <p:extLst>
@@ -4654,7 +4684,13 @@
   <p:cSld>
     <p:spTree>
       <p:nvGrpSpPr>
-        <p:cNvPr id="1" name=""/>
+        <p:cNvPr id="1" name="">
+          <a:extLst>
+            <a:ext uri="{FF2B5EF4-FFF2-40B4-BE49-F238E27FC236}">
+              <a16:creationId xmlns:a16="http://schemas.microsoft.com/office/drawing/2014/main" id="{89E224F9-ADCA-645B-0FB1-B15FAF2F6CDD}"/>
+            </a:ext>
+          </a:extLst>
+        </p:cNvPr>
         <p:cNvGrpSpPr/>
         <p:nvPr/>
       </p:nvGrpSpPr>
@@ -4668,7 +4704,13 @@
       </p:grpSpPr>
       <p:sp>
         <p:nvSpPr>
-          <p:cNvPr id="2" name="Title 1"/>
+          <p:cNvPr id="2" name="Title 1">
+            <a:extLst>
+              <a:ext uri="{FF2B5EF4-FFF2-40B4-BE49-F238E27FC236}">
+                <a16:creationId xmlns:a16="http://schemas.microsoft.com/office/drawing/2014/main" id="{7629E095-E953-1B02-2AD5-1B957F185EF7}"/>
+              </a:ext>
+            </a:extLst>
+          </p:cNvPr>
           <p:cNvSpPr>
             <a:spLocks noGrp="1"/>
           </p:cNvSpPr>
@@ -4678,8 +4720,8 @@
         </p:nvSpPr>
         <p:spPr>
           <a:xfrm>
-            <a:off x="1485900" y="0"/>
-            <a:ext cx="6172200" cy="1143000"/>
+            <a:off x="539690" y="171450"/>
+            <a:ext cx="8604310" cy="1143000"/>
           </a:xfrm>
         </p:spPr>
         <p:txBody>
@@ -4688,16 +4730,23 @@
           </a:bodyPr>
           <a:lstStyle/>
           <a:p>
-            <a:r>
-              <a:rPr lang="pt-BR" noProof="0"/>
-              <a:t>Recomendações práticas</a:t>
-            </a:r>
-          </a:p>
-        </p:txBody>
-      </p:sp>
-      <p:sp>
-        <p:nvSpPr>
-          <p:cNvPr id="3" name="Content Placeholder 2"/>
+            <a:pPr algn="ctr"/>
+            <a:r>
+              <a:rPr lang="pt-BR" sz="3600" noProof="0" dirty="0"/>
+              <a:t>Fatores que mais impactam a satisfação</a:t>
+            </a:r>
+          </a:p>
+        </p:txBody>
+      </p:sp>
+      <p:sp>
+        <p:nvSpPr>
+          <p:cNvPr id="3" name="Content Placeholder 2">
+            <a:extLst>
+              <a:ext uri="{FF2B5EF4-FFF2-40B4-BE49-F238E27FC236}">
+                <a16:creationId xmlns:a16="http://schemas.microsoft.com/office/drawing/2014/main" id="{5D0E23A3-4847-118C-7423-CE73E766023E}"/>
+              </a:ext>
+            </a:extLst>
+          </p:cNvPr>
           <p:cNvSpPr>
             <a:spLocks noGrp="1"/>
           </p:cNvSpPr>
@@ -4707,88 +4756,140 @@
         </p:nvSpPr>
         <p:spPr>
           <a:xfrm>
-            <a:off x="447496" y="1600201"/>
-            <a:ext cx="8249009" cy="4525963"/>
-          </a:xfrm>
-        </p:spPr>
-        <p:txBody>
-          <a:bodyPr/>
+            <a:off x="265801" y="1505310"/>
+            <a:ext cx="2867924" cy="4714515"/>
+          </a:xfrm>
+        </p:spPr>
+        <p:txBody>
+          <a:bodyPr>
+            <a:normAutofit lnSpcReduction="10000"/>
+          </a:bodyPr>
           <a:lstStyle/>
           <a:p>
             <a:pPr>
               <a:defRPr sz="2000"/>
             </a:pPr>
             <a:r>
-              <a:rPr lang="pt-BR" noProof="0"/>
-              <a:t>Plano de ação para atraso ≥ 4 dias: comunicação proativa + compensação.</a:t>
+              <a:rPr lang="pt-BR" b="1" noProof="0" dirty="0"/>
+              <a:t>Resumo analítico</a:t>
+            </a:r>
+            <a:r>
+              <a:rPr lang="pt-BR" noProof="0" dirty="0"/>
+              <a:t>:</a:t>
+            </a:r>
+            <a:br>
+              <a:rPr lang="pt-BR" noProof="0" dirty="0"/>
+            </a:br>
+            <a:br>
+              <a:rPr lang="pt-BR" noProof="0" dirty="0"/>
+            </a:br>
+            <a:r>
+              <a:rPr lang="pt-BR" noProof="0" dirty="0"/>
+              <a:t>Principais variáveis negativas:</a:t>
+            </a:r>
+          </a:p>
+          <a:p>
+            <a:pPr lvl="1">
+              <a:defRPr sz="2000"/>
+            </a:pPr>
+            <a:r>
+              <a:rPr lang="pt-BR" sz="1800" dirty="0"/>
+              <a:t>Dias para entrega</a:t>
+            </a:r>
+          </a:p>
+          <a:p>
+            <a:pPr lvl="1">
+              <a:defRPr sz="2000"/>
+            </a:pPr>
+            <a:r>
+              <a:rPr lang="pt-BR" sz="1800" noProof="0" dirty="0"/>
+              <a:t>Contatos com o serviço ao cliente</a:t>
+            </a:r>
+          </a:p>
+          <a:p>
+            <a:pPr lvl="1">
+              <a:defRPr sz="2000"/>
+            </a:pPr>
+            <a:r>
+              <a:rPr lang="pt-BR" sz="1800" dirty="0"/>
+              <a:t>Dias para resolução.</a:t>
+            </a:r>
+          </a:p>
+          <a:p>
+            <a:pPr lvl="1">
+              <a:defRPr sz="2000"/>
+            </a:pPr>
+            <a:r>
+              <a:rPr lang="pt-BR" sz="1800" noProof="0" dirty="0"/>
+              <a:t>Contagem de reclamações.</a:t>
             </a:r>
           </a:p>
           <a:p>
             <a:pPr>
               <a:defRPr sz="2000"/>
             </a:pPr>
-            <a:r>
-              <a:rPr lang="pt-BR" noProof="0" dirty="0"/>
-              <a:t>Priorizar root-cause de reclamações:</a:t>
-            </a:r>
+            <a:endParaRPr lang="pt-BR" sz="1800" dirty="0"/>
+          </a:p>
+          <a:p>
+            <a:pPr>
+              <a:defRPr sz="2000"/>
+            </a:pPr>
+            <a:r>
+              <a:rPr lang="pt-BR" sz="1800" dirty="0"/>
+              <a:t>Diversas variáveis não tiveram influência em NPS e CSAT.</a:t>
+            </a:r>
+            <a:endParaRPr lang="pt-BR" sz="1800" noProof="0" dirty="0"/>
           </a:p>
           <a:p>
             <a:pPr lvl="1">
               <a:defRPr sz="2000"/>
             </a:pPr>
-            <a:r>
-              <a:rPr lang="pt-BR" noProof="0" dirty="0"/>
-              <a:t>Embalagem.</a:t>
-            </a:r>
+            <a:endParaRPr lang="pt-BR" noProof="0" dirty="0"/>
           </a:p>
           <a:p>
             <a:pPr lvl="1">
               <a:defRPr sz="2000"/>
             </a:pPr>
-            <a:r>
-              <a:rPr lang="pt-BR" noProof="0" dirty="0"/>
-              <a:t>Transportadora.</a:t>
-            </a:r>
-          </a:p>
-          <a:p>
-            <a:pPr lvl="1">
-              <a:defRPr sz="2000"/>
-            </a:pPr>
-            <a:r>
-              <a:rPr lang="pt-BR" noProof="0" dirty="0"/>
-              <a:t>Promessa.</a:t>
-            </a:r>
-          </a:p>
-          <a:p>
-            <a:pPr lvl="1">
-              <a:defRPr sz="2000"/>
-            </a:pPr>
-            <a:r>
-              <a:rPr lang="pt-BR" noProof="0" dirty="0"/>
-              <a:t>Produto</a:t>
-            </a:r>
-          </a:p>
-          <a:p>
-            <a:pPr>
-              <a:defRPr sz="2000"/>
-            </a:pPr>
-            <a:r>
-              <a:rPr lang="pt-BR" noProof="0" dirty="0"/>
-              <a:t>Reduzir necessidade de contato: rastreio claro e expectativa de prazo.</a:t>
-            </a:r>
-          </a:p>
-          <a:p>
-            <a:pPr>
-              <a:defRPr sz="2000"/>
-            </a:pPr>
-            <a:r>
-              <a:rPr lang="pt-BR" noProof="0" dirty="0"/>
-              <a:t>Pilotar fila de risco com score preditivo antes da pesquisa NPS.</a:t>
-            </a:r>
-          </a:p>
-        </p:txBody>
-      </p:sp>
+            <a:endParaRPr lang="pt-BR" noProof="0" dirty="0"/>
+          </a:p>
+        </p:txBody>
+      </p:sp>
+      <p:pic>
+        <p:nvPicPr>
+          <p:cNvPr id="7" name="Imagem 6">
+            <a:extLst>
+              <a:ext uri="{FF2B5EF4-FFF2-40B4-BE49-F238E27FC236}">
+                <a16:creationId xmlns:a16="http://schemas.microsoft.com/office/drawing/2014/main" id="{E65BB6D2-F0CA-0D69-DB73-A5B33287B495}"/>
+              </a:ext>
+            </a:extLst>
+          </p:cNvPr>
+          <p:cNvPicPr>
+            <a:picLocks noChangeAspect="1"/>
+          </p:cNvPicPr>
+          <p:nvPr/>
+        </p:nvPicPr>
+        <p:blipFill>
+          <a:blip r:embed="rId2"/>
+          <a:stretch>
+            <a:fillRect/>
+          </a:stretch>
+        </p:blipFill>
+        <p:spPr>
+          <a:xfrm>
+            <a:off x="3154133" y="1261699"/>
+            <a:ext cx="5894617" cy="5177561"/>
+          </a:xfrm>
+          <a:prstGeom prst="rect">
+            <a:avLst/>
+          </a:prstGeom>
+        </p:spPr>
+      </p:pic>
     </p:spTree>
+    <p:extLst>
+      <p:ext uri="{BB962C8B-B14F-4D97-AF65-F5344CB8AC3E}">
+        <p14:creationId xmlns:p14="http://schemas.microsoft.com/office/powerpoint/2010/main" val="2351452049"/>
+      </p:ext>
+    </p:extLst>
   </p:cSld>
   <p:clrMapOvr>
     <a:masterClrMapping/>
@@ -4825,8 +4926,8 @@
         </p:nvSpPr>
         <p:spPr>
           <a:xfrm>
-            <a:off x="816275" y="0"/>
-            <a:ext cx="7511451" cy="1143000"/>
+            <a:off x="1485900" y="0"/>
+            <a:ext cx="6172200" cy="1143000"/>
           </a:xfrm>
         </p:spPr>
         <p:txBody>
@@ -4836,8 +4937,8 @@
           <a:lstStyle/>
           <a:p>
             <a:r>
-              <a:rPr lang="pt-BR" noProof="0" dirty="0"/>
-              <a:t>Modelo preditivo</a:t>
+              <a:rPr lang="pt-BR" noProof="0"/>
+              <a:t>Recomendações práticas</a:t>
             </a:r>
           </a:p>
         </p:txBody>
@@ -4854,8 +4955,8 @@
         </p:nvSpPr>
         <p:spPr>
           <a:xfrm>
-            <a:off x="723540" y="1246518"/>
-            <a:ext cx="7696919" cy="4525963"/>
+            <a:off x="447496" y="1600201"/>
+            <a:ext cx="8249009" cy="4525963"/>
           </a:xfrm>
         </p:spPr>
         <p:txBody>
@@ -4866,8 +4967,8 @@
               <a:defRPr sz="2000"/>
             </a:pPr>
             <a:r>
-              <a:rPr lang="pt-BR" noProof="0" dirty="0"/>
-              <a:t>Usa dados de pedido, logística e atendimento para estimar o NPS.</a:t>
+              <a:rPr lang="pt-BR" noProof="0"/>
+              <a:t>Plano de ação para atraso ≥ 4 dias: comunicação proativa + compensação.</a:t>
             </a:r>
           </a:p>
           <a:p>
@@ -4876,7 +4977,43 @@
             </a:pPr>
             <a:r>
               <a:rPr lang="pt-BR" noProof="0" dirty="0"/>
-              <a:t>Ajuda a priorizar onde logística e SAC agem antes da pesquisa.</a:t>
+              <a:t>Priorizar root-cause de reclamações:</a:t>
+            </a:r>
+          </a:p>
+          <a:p>
+            <a:pPr lvl="1">
+              <a:defRPr sz="2000"/>
+            </a:pPr>
+            <a:r>
+              <a:rPr lang="pt-BR" noProof="0" dirty="0"/>
+              <a:t>Embalagem.</a:t>
+            </a:r>
+          </a:p>
+          <a:p>
+            <a:pPr lvl="1">
+              <a:defRPr sz="2000"/>
+            </a:pPr>
+            <a:r>
+              <a:rPr lang="pt-BR" noProof="0" dirty="0"/>
+              <a:t>Transportadora.</a:t>
+            </a:r>
+          </a:p>
+          <a:p>
+            <a:pPr lvl="1">
+              <a:defRPr sz="2000"/>
+            </a:pPr>
+            <a:r>
+              <a:rPr lang="pt-BR" noProof="0" dirty="0"/>
+              <a:t>Promessa.</a:t>
+            </a:r>
+          </a:p>
+          <a:p>
+            <a:pPr lvl="1">
+              <a:defRPr sz="2000"/>
+            </a:pPr>
+            <a:r>
+              <a:rPr lang="pt-BR" noProof="0" dirty="0"/>
+              <a:t>Produto</a:t>
             </a:r>
           </a:p>
           <a:p>
@@ -4885,41 +5022,20 @@
             </a:pPr>
             <a:r>
               <a:rPr lang="pt-BR" noProof="0" dirty="0"/>
-              <a:t>Variáveis mais relevantes: atraso, reclamações e sinais de fricção no atendimento.</a:t>
-            </a:r>
-          </a:p>
-        </p:txBody>
-      </p:sp>
-      <p:pic>
-        <p:nvPicPr>
-          <p:cNvPr id="5" name="Imagem 4">
-            <a:extLst>
-              <a:ext uri="{FF2B5EF4-FFF2-40B4-BE49-F238E27FC236}">
-                <a16:creationId xmlns:a16="http://schemas.microsoft.com/office/drawing/2014/main" id="{CB669CA6-D147-16CB-02FD-C5849A4F87EA}"/>
-              </a:ext>
-            </a:extLst>
-          </p:cNvPr>
-          <p:cNvPicPr>
-            <a:picLocks noChangeAspect="1"/>
-          </p:cNvPicPr>
-          <p:nvPr/>
-        </p:nvPicPr>
-        <p:blipFill>
-          <a:blip r:embed="rId2"/>
-          <a:stretch>
-            <a:fillRect/>
-          </a:stretch>
-        </p:blipFill>
-        <p:spPr>
-          <a:xfrm>
-            <a:off x="2803584" y="2767023"/>
-            <a:ext cx="3536831" cy="3522375"/>
-          </a:xfrm>
-          <a:prstGeom prst="rect">
-            <a:avLst/>
-          </a:prstGeom>
-        </p:spPr>
-      </p:pic>
+              <a:t>Reduzir necessidade de contato: rastreio claro e expectativa de prazo.</a:t>
+            </a:r>
+          </a:p>
+          <a:p>
+            <a:pPr>
+              <a:defRPr sz="2000"/>
+            </a:pPr>
+            <a:r>
+              <a:rPr lang="pt-BR" noProof="0" dirty="0"/>
+              <a:t>Pilotar fila de risco com score preditivo antes da pesquisa NPS.</a:t>
+            </a:r>
+          </a:p>
+        </p:txBody>
+      </p:sp>
     </p:spTree>
   </p:cSld>
   <p:clrMapOvr>
@@ -4957,17 +5073,19 @@
         </p:nvSpPr>
         <p:spPr>
           <a:xfrm>
-            <a:off x="1485900" y="0"/>
-            <a:ext cx="6172200" cy="1143000"/>
-          </a:xfrm>
-        </p:spPr>
-        <p:txBody>
-          <a:bodyPr/>
+            <a:off x="816275" y="0"/>
+            <a:ext cx="7511451" cy="1143000"/>
+          </a:xfrm>
+        </p:spPr>
+        <p:txBody>
+          <a:bodyPr>
+            <a:normAutofit/>
+          </a:bodyPr>
           <a:lstStyle/>
           <a:p>
             <a:r>
-              <a:rPr lang="pt-BR" noProof="0"/>
-              <a:t>Limitações e riscos</a:t>
+              <a:rPr lang="pt-BR" noProof="0" dirty="0"/>
+              <a:t>Modelo preditivo</a:t>
             </a:r>
           </a:p>
         </p:txBody>
@@ -4984,8 +5102,8 @@
         </p:nvSpPr>
         <p:spPr>
           <a:xfrm>
-            <a:off x="395737" y="1600201"/>
-            <a:ext cx="8352526" cy="4525963"/>
+            <a:off x="723540" y="1246519"/>
+            <a:ext cx="4867635" cy="429882"/>
           </a:xfrm>
         </p:spPr>
         <p:txBody>
@@ -4996,27 +5114,129 @@
               <a:defRPr sz="2000"/>
             </a:pPr>
             <a:r>
-              <a:rPr lang="pt-BR" noProof="0"/>
-              <a:t>Correlação não implica causa: validar com pilotos e experimentos.</a:t>
-            </a:r>
-          </a:p>
-          <a:p>
-            <a:pPr>
-              <a:defRPr sz="2000"/>
-            </a:pPr>
-            <a:r>
-              <a:rPr lang="pt-BR" noProof="0" dirty="0"/>
-              <a:t>Modelo pode mudar com sazonalidade, greves ou mudança de transportadora.</a:t>
-            </a:r>
-          </a:p>
-          <a:p>
-            <a:pPr>
-              <a:defRPr sz="2000"/>
-            </a:pPr>
-            <a:r>
-              <a:rPr lang="pt-BR" noProof="0" dirty="0"/>
-              <a:t>Uso responsável: apoio à decisão, não punição automática de times ou clientes.</a:t>
-            </a:r>
+              <a:rPr lang="pt-BR" b="1" i="1" dirty="0"/>
+              <a:t>Mapa de prioridades do modelo</a:t>
+            </a:r>
+            <a:endParaRPr lang="pt-BR" noProof="0" dirty="0"/>
+          </a:p>
+        </p:txBody>
+      </p:sp>
+      <p:pic>
+        <p:nvPicPr>
+          <p:cNvPr id="9" name="Imagem 8">
+            <a:extLst>
+              <a:ext uri="{FF2B5EF4-FFF2-40B4-BE49-F238E27FC236}">
+                <a16:creationId xmlns:a16="http://schemas.microsoft.com/office/drawing/2014/main" id="{A906637F-C0FD-E253-8235-18884CCEF831}"/>
+              </a:ext>
+            </a:extLst>
+          </p:cNvPr>
+          <p:cNvPicPr>
+            <a:picLocks noChangeAspect="1"/>
+          </p:cNvPicPr>
+          <p:nvPr/>
+        </p:nvPicPr>
+        <p:blipFill>
+          <a:blip r:embed="rId2"/>
+          <a:stretch>
+            <a:fillRect/>
+          </a:stretch>
+        </p:blipFill>
+        <p:spPr>
+          <a:xfrm>
+            <a:off x="723540" y="1757605"/>
+            <a:ext cx="5010510" cy="3092491"/>
+          </a:xfrm>
+          <a:prstGeom prst="rect">
+            <a:avLst/>
+          </a:prstGeom>
+        </p:spPr>
+      </p:pic>
+      <p:sp>
+        <p:nvSpPr>
+          <p:cNvPr id="11" name="CaixaDeTexto 10">
+            <a:extLst>
+              <a:ext uri="{FF2B5EF4-FFF2-40B4-BE49-F238E27FC236}">
+                <a16:creationId xmlns:a16="http://schemas.microsoft.com/office/drawing/2014/main" id="{3F81420E-C21D-4479-414F-F0A5411601D5}"/>
+              </a:ext>
+            </a:extLst>
+          </p:cNvPr>
+          <p:cNvSpPr txBox="1"/>
+          <p:nvPr/>
+        </p:nvSpPr>
+        <p:spPr>
+          <a:xfrm>
+            <a:off x="3733800" y="5033817"/>
+            <a:ext cx="5105759" cy="1477328"/>
+          </a:xfrm>
+          <a:prstGeom prst="rect">
+            <a:avLst/>
+          </a:prstGeom>
+          <a:noFill/>
+        </p:spPr>
+        <p:txBody>
+          <a:bodyPr wrap="square">
+            <a:spAutoFit/>
+          </a:bodyPr>
+          <a:lstStyle/>
+          <a:p>
+            <a:pPr algn="just"/>
+            <a:r>
+              <a:rPr lang="pt-BR" b="0" i="1" dirty="0">
+                <a:effectLst/>
+                <a:latin typeface="Segoe WPC"/>
+              </a:rPr>
+              <a:t>Este gráfico mostra </a:t>
+            </a:r>
+            <a:r>
+              <a:rPr lang="pt-BR" b="1" i="1" dirty="0">
+                <a:effectLst/>
+                <a:latin typeface="Segoe WPC"/>
+              </a:rPr>
+              <a:t>o que o modelo usa mais</a:t>
+            </a:r>
+            <a:r>
+              <a:rPr lang="pt-BR" b="0" i="1" dirty="0">
+                <a:effectLst/>
+                <a:latin typeface="Segoe WPC"/>
+              </a:rPr>
+              <a:t> para estimar o NPS: principalmente sinais de </a:t>
+            </a:r>
+            <a:r>
+              <a:rPr lang="pt-BR" b="1" i="1" dirty="0">
+                <a:effectLst/>
+                <a:latin typeface="Segoe WPC"/>
+              </a:rPr>
+              <a:t>problema na jornada</a:t>
+            </a:r>
+            <a:r>
+              <a:rPr lang="pt-BR" b="0" i="1" dirty="0">
+                <a:effectLst/>
+                <a:latin typeface="Segoe WPC"/>
+              </a:rPr>
+              <a:t> (atraso, reclamações) e também variáveis que </a:t>
+            </a:r>
+            <a:r>
+              <a:rPr lang="pt-BR" b="1" i="1" dirty="0">
+                <a:effectLst/>
+                <a:latin typeface="Segoe WPC"/>
+              </a:rPr>
+              <a:t>andam muito juntas</a:t>
+            </a:r>
+            <a:r>
+              <a:rPr lang="pt-BR" b="0" i="1" dirty="0">
+                <a:effectLst/>
+                <a:latin typeface="Segoe WPC"/>
+              </a:rPr>
+              <a:t> com o resultado, como a </a:t>
+            </a:r>
+            <a:r>
+              <a:rPr lang="pt-BR" b="1" i="1" dirty="0">
+                <a:effectLst/>
+                <a:latin typeface="Segoe WPC"/>
+              </a:rPr>
+              <a:t>recompra recente.</a:t>
+            </a:r>
+            <a:endParaRPr lang="pt-BR" dirty="0"/>
           </a:p>
         </p:txBody>
       </p:sp>
@@ -5029,6 +5249,261 @@
 </file>
 
 <file path=ppt/slides/slide13.xml><?xml version="1.0" encoding="utf-8"?>
+<p:sld xmlns:a="http://schemas.openxmlformats.org/drawingml/2006/main" xmlns:r="http://schemas.openxmlformats.org/officeDocument/2006/relationships" xmlns:p="http://schemas.openxmlformats.org/presentationml/2006/main">
+  <p:cSld>
+    <p:spTree>
+      <p:nvGrpSpPr>
+        <p:cNvPr id="1" name="">
+          <a:extLst>
+            <a:ext uri="{FF2B5EF4-FFF2-40B4-BE49-F238E27FC236}">
+              <a16:creationId xmlns:a16="http://schemas.microsoft.com/office/drawing/2014/main" id="{9D05A96A-A7AB-79FE-68DB-5955DCBDF0C1}"/>
+            </a:ext>
+          </a:extLst>
+        </p:cNvPr>
+        <p:cNvGrpSpPr/>
+        <p:nvPr/>
+      </p:nvGrpSpPr>
+      <p:grpSpPr>
+        <a:xfrm>
+          <a:off x="0" y="0"/>
+          <a:ext cx="0" cy="0"/>
+          <a:chOff x="0" y="0"/>
+          <a:chExt cx="0" cy="0"/>
+        </a:xfrm>
+      </p:grpSpPr>
+      <p:sp>
+        <p:nvSpPr>
+          <p:cNvPr id="2" name="Title 1">
+            <a:extLst>
+              <a:ext uri="{FF2B5EF4-FFF2-40B4-BE49-F238E27FC236}">
+                <a16:creationId xmlns:a16="http://schemas.microsoft.com/office/drawing/2014/main" id="{E2D4DAD9-C868-AB34-CAEA-BCC9426B7C62}"/>
+              </a:ext>
+            </a:extLst>
+          </p:cNvPr>
+          <p:cNvSpPr>
+            <a:spLocks noGrp="1"/>
+          </p:cNvSpPr>
+          <p:nvPr>
+            <p:ph type="title"/>
+          </p:nvPr>
+        </p:nvSpPr>
+        <p:spPr>
+          <a:xfrm>
+            <a:off x="816275" y="0"/>
+            <a:ext cx="7511451" cy="1143000"/>
+          </a:xfrm>
+        </p:spPr>
+        <p:txBody>
+          <a:bodyPr>
+            <a:normAutofit/>
+          </a:bodyPr>
+          <a:lstStyle/>
+          <a:p>
+            <a:r>
+              <a:rPr lang="pt-BR" noProof="0" dirty="0"/>
+              <a:t>Modelo preditivo</a:t>
+            </a:r>
+          </a:p>
+        </p:txBody>
+      </p:sp>
+      <p:sp>
+        <p:nvSpPr>
+          <p:cNvPr id="3" name="Content Placeholder 2">
+            <a:extLst>
+              <a:ext uri="{FF2B5EF4-FFF2-40B4-BE49-F238E27FC236}">
+                <a16:creationId xmlns:a16="http://schemas.microsoft.com/office/drawing/2014/main" id="{4A21A60B-12B4-8DBA-8307-7A51FEDE92C7}"/>
+              </a:ext>
+            </a:extLst>
+          </p:cNvPr>
+          <p:cNvSpPr>
+            <a:spLocks noGrp="1"/>
+          </p:cNvSpPr>
+          <p:nvPr>
+            <p:ph idx="1"/>
+          </p:nvPr>
+        </p:nvSpPr>
+        <p:spPr>
+          <a:xfrm>
+            <a:off x="723540" y="1246518"/>
+            <a:ext cx="7696919" cy="4525963"/>
+          </a:xfrm>
+        </p:spPr>
+        <p:txBody>
+          <a:bodyPr/>
+          <a:lstStyle/>
+          <a:p>
+            <a:pPr>
+              <a:defRPr sz="2000"/>
+            </a:pPr>
+            <a:r>
+              <a:rPr lang="pt-BR" noProof="0" dirty="0"/>
+              <a:t>Usa dados de pedido, logística e atendimento para estimar o NPS.</a:t>
+            </a:r>
+          </a:p>
+          <a:p>
+            <a:pPr>
+              <a:defRPr sz="2000"/>
+            </a:pPr>
+            <a:r>
+              <a:rPr lang="pt-BR" noProof="0" dirty="0"/>
+              <a:t>Ajuda a priorizar onde logística e SAC agem antes da pesquisa.</a:t>
+            </a:r>
+          </a:p>
+          <a:p>
+            <a:pPr>
+              <a:defRPr sz="2000"/>
+            </a:pPr>
+            <a:r>
+              <a:rPr lang="pt-BR" noProof="0" dirty="0"/>
+              <a:t>Variáveis mais relevantes: atraso, reclamações e sinais de fricção no atendimento.</a:t>
+            </a:r>
+          </a:p>
+        </p:txBody>
+      </p:sp>
+      <p:pic>
+        <p:nvPicPr>
+          <p:cNvPr id="5" name="Imagem 4">
+            <a:extLst>
+              <a:ext uri="{FF2B5EF4-FFF2-40B4-BE49-F238E27FC236}">
+                <a16:creationId xmlns:a16="http://schemas.microsoft.com/office/drawing/2014/main" id="{83958369-66DA-3BCE-4D91-ABF5235A0AE0}"/>
+              </a:ext>
+            </a:extLst>
+          </p:cNvPr>
+          <p:cNvPicPr>
+            <a:picLocks noChangeAspect="1"/>
+          </p:cNvPicPr>
+          <p:nvPr/>
+        </p:nvPicPr>
+        <p:blipFill>
+          <a:blip r:embed="rId2"/>
+          <a:stretch>
+            <a:fillRect/>
+          </a:stretch>
+        </p:blipFill>
+        <p:spPr>
+          <a:xfrm>
+            <a:off x="2803584" y="2767023"/>
+            <a:ext cx="3536831" cy="3522375"/>
+          </a:xfrm>
+          <a:prstGeom prst="rect">
+            <a:avLst/>
+          </a:prstGeom>
+        </p:spPr>
+      </p:pic>
+    </p:spTree>
+    <p:extLst>
+      <p:ext uri="{BB962C8B-B14F-4D97-AF65-F5344CB8AC3E}">
+        <p14:creationId xmlns:p14="http://schemas.microsoft.com/office/powerpoint/2010/main" val="3224078364"/>
+      </p:ext>
+    </p:extLst>
+  </p:cSld>
+  <p:clrMapOvr>
+    <a:masterClrMapping/>
+  </p:clrMapOvr>
+</p:sld>
+</file>
+
+<file path=ppt/slides/slide14.xml><?xml version="1.0" encoding="utf-8"?>
+<p:sld xmlns:a="http://schemas.openxmlformats.org/drawingml/2006/main" xmlns:r="http://schemas.openxmlformats.org/officeDocument/2006/relationships" xmlns:p="http://schemas.openxmlformats.org/presentationml/2006/main">
+  <p:cSld>
+    <p:spTree>
+      <p:nvGrpSpPr>
+        <p:cNvPr id="1" name=""/>
+        <p:cNvGrpSpPr/>
+        <p:nvPr/>
+      </p:nvGrpSpPr>
+      <p:grpSpPr>
+        <a:xfrm>
+          <a:off x="0" y="0"/>
+          <a:ext cx="0" cy="0"/>
+          <a:chOff x="0" y="0"/>
+          <a:chExt cx="0" cy="0"/>
+        </a:xfrm>
+      </p:grpSpPr>
+      <p:sp>
+        <p:nvSpPr>
+          <p:cNvPr id="2" name="Title 1"/>
+          <p:cNvSpPr>
+            <a:spLocks noGrp="1"/>
+          </p:cNvSpPr>
+          <p:nvPr>
+            <p:ph type="title"/>
+          </p:nvPr>
+        </p:nvSpPr>
+        <p:spPr>
+          <a:xfrm>
+            <a:off x="1485900" y="0"/>
+            <a:ext cx="6172200" cy="1143000"/>
+          </a:xfrm>
+        </p:spPr>
+        <p:txBody>
+          <a:bodyPr/>
+          <a:lstStyle/>
+          <a:p>
+            <a:r>
+              <a:rPr lang="pt-BR" noProof="0"/>
+              <a:t>Limitações e riscos</a:t>
+            </a:r>
+          </a:p>
+        </p:txBody>
+      </p:sp>
+      <p:sp>
+        <p:nvSpPr>
+          <p:cNvPr id="3" name="Content Placeholder 2"/>
+          <p:cNvSpPr>
+            <a:spLocks noGrp="1"/>
+          </p:cNvSpPr>
+          <p:nvPr>
+            <p:ph idx="1"/>
+          </p:nvPr>
+        </p:nvSpPr>
+        <p:spPr>
+          <a:xfrm>
+            <a:off x="395737" y="1600201"/>
+            <a:ext cx="8352526" cy="4525963"/>
+          </a:xfrm>
+        </p:spPr>
+        <p:txBody>
+          <a:bodyPr/>
+          <a:lstStyle/>
+          <a:p>
+            <a:pPr>
+              <a:defRPr sz="2000"/>
+            </a:pPr>
+            <a:r>
+              <a:rPr lang="pt-BR" noProof="0"/>
+              <a:t>Correlação não implica causa: validar com pilotos e experimentos.</a:t>
+            </a:r>
+          </a:p>
+          <a:p>
+            <a:pPr>
+              <a:defRPr sz="2000"/>
+            </a:pPr>
+            <a:r>
+              <a:rPr lang="pt-BR" noProof="0" dirty="0"/>
+              <a:t>Modelo pode mudar com sazonalidade, greves ou mudança de transportadora.</a:t>
+            </a:r>
+          </a:p>
+          <a:p>
+            <a:pPr>
+              <a:defRPr sz="2000"/>
+            </a:pPr>
+            <a:r>
+              <a:rPr lang="pt-BR" noProof="0" dirty="0"/>
+              <a:t>Uso responsável: apoio à decisão, não punição automática de times ou clientes.</a:t>
+            </a:r>
+          </a:p>
+        </p:txBody>
+      </p:sp>
+    </p:spTree>
+  </p:cSld>
+  <p:clrMapOvr>
+    <a:masterClrMapping/>
+  </p:clrMapOvr>
+</p:sld>
+</file>
+
+<file path=ppt/slides/slide15.xml><?xml version="1.0" encoding="utf-8"?>
 <p:sld xmlns:a="http://schemas.openxmlformats.org/drawingml/2006/main" xmlns:r="http://schemas.openxmlformats.org/officeDocument/2006/relationships" xmlns:p="http://schemas.openxmlformats.org/presentationml/2006/main">
   <p:cSld>
     <p:spTree>
@@ -6441,6 +6916,154 @@
   <p:cSld>
     <p:spTree>
       <p:nvGrpSpPr>
+        <p:cNvPr id="1" name="">
+          <a:extLst>
+            <a:ext uri="{FF2B5EF4-FFF2-40B4-BE49-F238E27FC236}">
+              <a16:creationId xmlns:a16="http://schemas.microsoft.com/office/drawing/2014/main" id="{DCF85F83-F5F9-1A42-673B-6D6423E9CD9C}"/>
+            </a:ext>
+          </a:extLst>
+        </p:cNvPr>
+        <p:cNvGrpSpPr/>
+        <p:nvPr/>
+      </p:nvGrpSpPr>
+      <p:grpSpPr>
+        <a:xfrm>
+          <a:off x="0" y="0"/>
+          <a:ext cx="0" cy="0"/>
+          <a:chOff x="0" y="0"/>
+          <a:chExt cx="0" cy="0"/>
+        </a:xfrm>
+      </p:grpSpPr>
+      <p:sp>
+        <p:nvSpPr>
+          <p:cNvPr id="2" name="Title 1">
+            <a:extLst>
+              <a:ext uri="{FF2B5EF4-FFF2-40B4-BE49-F238E27FC236}">
+                <a16:creationId xmlns:a16="http://schemas.microsoft.com/office/drawing/2014/main" id="{F402AE01-DCB4-4F40-88C7-FDB74ECF1EE8}"/>
+              </a:ext>
+            </a:extLst>
+          </p:cNvPr>
+          <p:cNvSpPr>
+            <a:spLocks noGrp="1"/>
+          </p:cNvSpPr>
+          <p:nvPr>
+            <p:ph type="title"/>
+          </p:nvPr>
+        </p:nvSpPr>
+        <p:spPr>
+          <a:xfrm>
+            <a:off x="1485900" y="133350"/>
+            <a:ext cx="6172200" cy="1143000"/>
+          </a:xfrm>
+        </p:spPr>
+        <p:txBody>
+          <a:bodyPr>
+            <a:normAutofit fontScale="90000"/>
+          </a:bodyPr>
+          <a:lstStyle/>
+          <a:p>
+            <a:r>
+              <a:rPr lang="pt-BR" noProof="0" dirty="0"/>
+              <a:t>Principais insights da EDA</a:t>
+            </a:r>
+          </a:p>
+        </p:txBody>
+      </p:sp>
+      <p:sp>
+        <p:nvSpPr>
+          <p:cNvPr id="3" name="Content Placeholder 2">
+            <a:extLst>
+              <a:ext uri="{FF2B5EF4-FFF2-40B4-BE49-F238E27FC236}">
+                <a16:creationId xmlns:a16="http://schemas.microsoft.com/office/drawing/2014/main" id="{E3B0A45C-4A54-CEE6-A809-9E295663986A}"/>
+              </a:ext>
+            </a:extLst>
+          </p:cNvPr>
+          <p:cNvSpPr>
+            <a:spLocks noGrp="1"/>
+          </p:cNvSpPr>
+          <p:nvPr>
+            <p:ph idx="1"/>
+          </p:nvPr>
+        </p:nvSpPr>
+        <p:spPr>
+          <a:xfrm>
+            <a:off x="590228" y="1375476"/>
+            <a:ext cx="8306122" cy="4525963"/>
+          </a:xfrm>
+        </p:spPr>
+        <p:txBody>
+          <a:bodyPr>
+            <a:normAutofit/>
+          </a:bodyPr>
+          <a:lstStyle/>
+          <a:p>
+            <a:pPr>
+              <a:defRPr sz="2000"/>
+            </a:pPr>
+            <a:r>
+              <a:rPr lang="pt-BR" dirty="0"/>
+              <a:t>Onde a experiência quebra:</a:t>
+            </a:r>
+          </a:p>
+          <a:p>
+            <a:pPr lvl="1">
+              <a:defRPr sz="2000"/>
+            </a:pPr>
+            <a:r>
+              <a:rPr lang="pt-BR" noProof="0" dirty="0"/>
+              <a:t>A combinação de mais de 3 reclamações e mais de 4 dias de atraso mostra claramente o impacto no NPS.</a:t>
+            </a:r>
+          </a:p>
+        </p:txBody>
+      </p:sp>
+      <p:pic>
+        <p:nvPicPr>
+          <p:cNvPr id="5" name="Imagem 4">
+            <a:extLst>
+              <a:ext uri="{FF2B5EF4-FFF2-40B4-BE49-F238E27FC236}">
+                <a16:creationId xmlns:a16="http://schemas.microsoft.com/office/drawing/2014/main" id="{5327509B-2D77-0A21-69E4-0674D22E543B}"/>
+              </a:ext>
+            </a:extLst>
+          </p:cNvPr>
+          <p:cNvPicPr>
+            <a:picLocks noChangeAspect="1"/>
+          </p:cNvPicPr>
+          <p:nvPr/>
+        </p:nvPicPr>
+        <p:blipFill>
+          <a:blip r:embed="rId2"/>
+          <a:stretch>
+            <a:fillRect/>
+          </a:stretch>
+        </p:blipFill>
+        <p:spPr>
+          <a:xfrm>
+            <a:off x="1431392" y="2686050"/>
+            <a:ext cx="6623794" cy="3689938"/>
+          </a:xfrm>
+          <a:prstGeom prst="rect">
+            <a:avLst/>
+          </a:prstGeom>
+        </p:spPr>
+      </p:pic>
+    </p:spTree>
+    <p:extLst>
+      <p:ext uri="{BB962C8B-B14F-4D97-AF65-F5344CB8AC3E}">
+        <p14:creationId xmlns:p14="http://schemas.microsoft.com/office/powerpoint/2010/main" val="43126493"/>
+      </p:ext>
+    </p:extLst>
+  </p:cSld>
+  <p:clrMapOvr>
+    <a:masterClrMapping/>
+  </p:clrMapOvr>
+</p:sld>
+</file>
+
+<file path=ppt/slides/slide9.xml><?xml version="1.0" encoding="utf-8"?>
+<p:sld xmlns:a="http://schemas.openxmlformats.org/drawingml/2006/main" xmlns:r="http://schemas.openxmlformats.org/officeDocument/2006/relationships" xmlns:p="http://schemas.openxmlformats.org/presentationml/2006/main">
+  <p:cSld>
+    <p:spTree>
+      <p:nvGrpSpPr>
         <p:cNvPr id="1" name=""/>
         <p:cNvGrpSpPr/>
         <p:nvPr/>
@@ -6579,141 +7202,6 @@
         </p:txBody>
       </p:sp>
     </p:spTree>
-  </p:cSld>
-  <p:clrMapOvr>
-    <a:masterClrMapping/>
-  </p:clrMapOvr>
-</p:sld>
-</file>
-
-<file path=ppt/slides/slide9.xml><?xml version="1.0" encoding="utf-8"?>
-<p:sld xmlns:a="http://schemas.openxmlformats.org/drawingml/2006/main" xmlns:r="http://schemas.openxmlformats.org/officeDocument/2006/relationships" xmlns:p="http://schemas.openxmlformats.org/presentationml/2006/main">
-  <p:cSld>
-    <p:spTree>
-      <p:nvGrpSpPr>
-        <p:cNvPr id="1" name="">
-          <a:extLst>
-            <a:ext uri="{FF2B5EF4-FFF2-40B4-BE49-F238E27FC236}">
-              <a16:creationId xmlns:a16="http://schemas.microsoft.com/office/drawing/2014/main" id="{89E224F9-ADCA-645B-0FB1-B15FAF2F6CDD}"/>
-            </a:ext>
-          </a:extLst>
-        </p:cNvPr>
-        <p:cNvGrpSpPr/>
-        <p:nvPr/>
-      </p:nvGrpSpPr>
-      <p:grpSpPr>
-        <a:xfrm>
-          <a:off x="0" y="0"/>
-          <a:ext cx="0" cy="0"/>
-          <a:chOff x="0" y="0"/>
-          <a:chExt cx="0" cy="0"/>
-        </a:xfrm>
-      </p:grpSpPr>
-      <p:sp>
-        <p:nvSpPr>
-          <p:cNvPr id="2" name="Title 1">
-            <a:extLst>
-              <a:ext uri="{FF2B5EF4-FFF2-40B4-BE49-F238E27FC236}">
-                <a16:creationId xmlns:a16="http://schemas.microsoft.com/office/drawing/2014/main" id="{7629E095-E953-1B02-2AD5-1B957F185EF7}"/>
-              </a:ext>
-            </a:extLst>
-          </p:cNvPr>
-          <p:cNvSpPr>
-            <a:spLocks noGrp="1"/>
-          </p:cNvSpPr>
-          <p:nvPr>
-            <p:ph type="title"/>
-          </p:nvPr>
-        </p:nvSpPr>
-        <p:spPr>
-          <a:xfrm>
-            <a:off x="539690" y="171450"/>
-            <a:ext cx="8604310" cy="1143000"/>
-          </a:xfrm>
-        </p:spPr>
-        <p:txBody>
-          <a:bodyPr>
-            <a:normAutofit/>
-          </a:bodyPr>
-          <a:lstStyle/>
-          <a:p>
-            <a:pPr algn="ctr"/>
-            <a:r>
-              <a:rPr lang="pt-BR" sz="3600" noProof="0" dirty="0"/>
-              <a:t>Fatores que mais impactam a satisfação</a:t>
-            </a:r>
-          </a:p>
-        </p:txBody>
-      </p:sp>
-      <p:sp>
-        <p:nvSpPr>
-          <p:cNvPr id="3" name="Content Placeholder 2">
-            <a:extLst>
-              <a:ext uri="{FF2B5EF4-FFF2-40B4-BE49-F238E27FC236}">
-                <a16:creationId xmlns:a16="http://schemas.microsoft.com/office/drawing/2014/main" id="{5D0E23A3-4847-118C-7423-CE73E766023E}"/>
-              </a:ext>
-            </a:extLst>
-          </p:cNvPr>
-          <p:cNvSpPr>
-            <a:spLocks noGrp="1"/>
-          </p:cNvSpPr>
-          <p:nvPr>
-            <p:ph idx="1"/>
-          </p:nvPr>
-        </p:nvSpPr>
-        <p:spPr>
-          <a:xfrm>
-            <a:off x="465826" y="1505310"/>
-            <a:ext cx="8134710" cy="4525963"/>
-          </a:xfrm>
-        </p:spPr>
-        <p:txBody>
-          <a:bodyPr/>
-          <a:lstStyle/>
-          <a:p>
-            <a:pPr>
-              <a:defRPr sz="2000"/>
-            </a:pPr>
-            <a:r>
-              <a:rPr lang="pt-BR" noProof="0" dirty="0"/>
-              <a:t>Logística: dias de atraso e tentativas de entrega.</a:t>
-            </a:r>
-          </a:p>
-          <a:p>
-            <a:pPr>
-              <a:defRPr sz="2000"/>
-            </a:pPr>
-            <a:r>
-              <a:rPr lang="pt-BR" noProof="0" dirty="0"/>
-              <a:t>Qualidade / volume de reclamações e tempo de resolução.</a:t>
-            </a:r>
-          </a:p>
-          <a:p>
-            <a:pPr>
-              <a:defRPr sz="2000"/>
-            </a:pPr>
-            <a:r>
-              <a:rPr lang="pt-BR" noProof="0" dirty="0"/>
-              <a:t>Pressão no SAC: cada contato extra sinaliza jornada problemática.</a:t>
-            </a:r>
-          </a:p>
-          <a:p>
-            <a:pPr>
-              <a:defRPr sz="2000"/>
-            </a:pPr>
-            <a:r>
-              <a:rPr lang="pt-BR" noProof="0" dirty="0"/>
-              <a:t>CSAT interno acompanha o NPS — bom alinhamento de indicadores.</a:t>
-            </a:r>
-          </a:p>
-        </p:txBody>
-      </p:sp>
-    </p:spTree>
-    <p:extLst>
-      <p:ext uri="{BB962C8B-B14F-4D97-AF65-F5344CB8AC3E}">
-        <p14:creationId xmlns:p14="http://schemas.microsoft.com/office/powerpoint/2010/main" val="2351452049"/>
-      </p:ext>
-    </p:extLst>
   </p:cSld>
   <p:clrMapOvr>
     <a:masterClrMapping/>

</xml_diff>